<commit_message>
Text in last slide modified
</commit_message>
<xml_diff>
--- a/docs/BIS_Portfolio_Deck.pptx
+++ b/docs/BIS_Portfolio_Deck.pptx
@@ -312,7 +312,7 @@
           <a:p>
             <a:fld id="{5BCAD085-E8A6-8845-BD4E-CB4CCA059FC4}" type="datetimeFigureOut">
               <a:rPr lang="en-US" smtClean="0"/>
-              <a:t>5/4/2026</a:t>
+              <a:t>5/6/2026</a:t>
             </a:fld>
             <a:endParaRPr lang="en-US"/>
           </a:p>
@@ -480,7 +480,7 @@
           <a:p>
             <a:fld id="{5BCAD085-E8A6-8845-BD4E-CB4CCA059FC4}" type="datetimeFigureOut">
               <a:rPr lang="en-US" smtClean="0"/>
-              <a:t>5/4/2026</a:t>
+              <a:t>5/6/2026</a:t>
             </a:fld>
             <a:endParaRPr lang="en-US"/>
           </a:p>
@@ -658,7 +658,7 @@
           <a:p>
             <a:fld id="{5BCAD085-E8A6-8845-BD4E-CB4CCA059FC4}" type="datetimeFigureOut">
               <a:rPr lang="en-US" smtClean="0"/>
-              <a:t>5/4/2026</a:t>
+              <a:t>5/6/2026</a:t>
             </a:fld>
             <a:endParaRPr lang="en-US"/>
           </a:p>
@@ -826,7 +826,7 @@
           <a:p>
             <a:fld id="{5BCAD085-E8A6-8845-BD4E-CB4CCA059FC4}" type="datetimeFigureOut">
               <a:rPr lang="en-US" smtClean="0"/>
-              <a:t>5/4/2026</a:t>
+              <a:t>5/6/2026</a:t>
             </a:fld>
             <a:endParaRPr lang="en-US"/>
           </a:p>
@@ -1071,7 +1071,7 @@
           <a:p>
             <a:fld id="{5BCAD085-E8A6-8845-BD4E-CB4CCA059FC4}" type="datetimeFigureOut">
               <a:rPr lang="en-US" smtClean="0"/>
-              <a:t>5/4/2026</a:t>
+              <a:t>5/6/2026</a:t>
             </a:fld>
             <a:endParaRPr lang="en-US"/>
           </a:p>
@@ -1356,7 +1356,7 @@
           <a:p>
             <a:fld id="{5BCAD085-E8A6-8845-BD4E-CB4CCA059FC4}" type="datetimeFigureOut">
               <a:rPr lang="en-US" smtClean="0"/>
-              <a:t>5/4/2026</a:t>
+              <a:t>5/6/2026</a:t>
             </a:fld>
             <a:endParaRPr lang="en-US"/>
           </a:p>
@@ -1775,7 +1775,7 @@
           <a:p>
             <a:fld id="{5BCAD085-E8A6-8845-BD4E-CB4CCA059FC4}" type="datetimeFigureOut">
               <a:rPr lang="en-US" smtClean="0"/>
-              <a:t>5/4/2026</a:t>
+              <a:t>5/6/2026</a:t>
             </a:fld>
             <a:endParaRPr lang="en-US"/>
           </a:p>
@@ -1892,7 +1892,7 @@
           <a:p>
             <a:fld id="{5BCAD085-E8A6-8845-BD4E-CB4CCA059FC4}" type="datetimeFigureOut">
               <a:rPr lang="en-US" smtClean="0"/>
-              <a:t>5/4/2026</a:t>
+              <a:t>5/6/2026</a:t>
             </a:fld>
             <a:endParaRPr lang="en-US"/>
           </a:p>
@@ -1987,7 +1987,7 @@
           <a:p>
             <a:fld id="{5BCAD085-E8A6-8845-BD4E-CB4CCA059FC4}" type="datetimeFigureOut">
               <a:rPr lang="en-US" smtClean="0"/>
-              <a:t>5/4/2026</a:t>
+              <a:t>5/6/2026</a:t>
             </a:fld>
             <a:endParaRPr lang="en-US"/>
           </a:p>
@@ -2262,7 +2262,7 @@
           <a:p>
             <a:fld id="{5BCAD085-E8A6-8845-BD4E-CB4CCA059FC4}" type="datetimeFigureOut">
               <a:rPr lang="en-US" smtClean="0"/>
-              <a:t>5/4/2026</a:t>
+              <a:t>5/6/2026</a:t>
             </a:fld>
             <a:endParaRPr lang="en-US"/>
           </a:p>
@@ -2514,7 +2514,7 @@
           <a:p>
             <a:fld id="{5BCAD085-E8A6-8845-BD4E-CB4CCA059FC4}" type="datetimeFigureOut">
               <a:rPr lang="en-US" smtClean="0"/>
-              <a:t>5/4/2026</a:t>
+              <a:t>5/6/2026</a:t>
             </a:fld>
             <a:endParaRPr lang="en-US"/>
           </a:p>
@@ -2725,7 +2725,7 @@
           <a:p>
             <a:fld id="{5BCAD085-E8A6-8845-BD4E-CB4CCA059FC4}" type="datetimeFigureOut">
               <a:rPr lang="en-US" smtClean="0"/>
-              <a:t>5/4/2026</a:t>
+              <a:t>5/6/2026</a:t>
             </a:fld>
             <a:endParaRPr lang="en-US"/>
           </a:p>
@@ -3705,8 +3705,8 @@
           <a:noFill/>
         </p:spPr>
       </p:pic>
-      <mc:AlternateContent xmlns:mc="http://schemas.openxmlformats.org/markup-compatibility/2006">
-        <mc:Choice xmlns:we="http://schemas.microsoft.com/office/webextensions/webextension/2010/11" xmlns:pca="http://schemas.microsoft.com/office/powerpoint/2013/contentapp" Requires="we pca">
+      <mc:AlternateContent xmlns:mc="http://schemas.openxmlformats.org/markup-compatibility/2006" xmlns:we="http://schemas.microsoft.com/office/webextensions/webextension/2010/11" xmlns:pca="http://schemas.microsoft.com/office/powerpoint/2013/contentapp">
+        <mc:Choice Requires="we pca">
           <p:graphicFrame>
             <p:nvGraphicFramePr>
               <p:cNvPr id="2" name="Add-in" descr="Add-in content for Microsoft Power BI."/>
@@ -3726,7 +3726,7 @@
             </a:graphic>
           </p:graphicFrame>
         </mc:Choice>
-        <mc:Fallback>
+        <mc:Fallback xmlns="">
           <p:pic>
             <p:nvPicPr>
               <p:cNvPr id="2" name="Add-in" descr="Add-in content for Microsoft Power BI."/>
@@ -3753,8 +3753,8 @@
           </p:pic>
         </mc:Fallback>
       </mc:AlternateContent>
-      <mc:AlternateContent xmlns:mc="http://schemas.openxmlformats.org/markup-compatibility/2006">
-        <mc:Choice xmlns:we="http://schemas.microsoft.com/office/webextensions/webextension/2010/11" xmlns:pca="http://schemas.microsoft.com/office/powerpoint/2013/contentapp" Requires="we pca">
+      <mc:AlternateContent xmlns:mc="http://schemas.openxmlformats.org/markup-compatibility/2006" xmlns:we="http://schemas.microsoft.com/office/webextensions/webextension/2010/11" xmlns:pca="http://schemas.microsoft.com/office/powerpoint/2013/contentapp">
+        <mc:Choice Requires="we pca">
           <p:graphicFrame>
             <p:nvGraphicFramePr>
               <p:cNvPr id="3" name="Add-in" descr="Add-in content for Microsoft Power BI.">
@@ -3780,7 +3780,7 @@
             </a:graphic>
           </p:graphicFrame>
         </mc:Choice>
-        <mc:Fallback>
+        <mc:Fallback xmlns="">
           <p:pic>
             <p:nvPicPr>
               <p:cNvPr id="3" name="Add-in" descr="Add-in content for Microsoft Power BI.">
@@ -3976,41 +3976,6 @@
       </p:sp>
       <p:sp>
         <p:nvSpPr>
-          <p:cNvPr id="5" name="TextBox 4"/>
-          <p:cNvSpPr txBox="1"/>
-          <p:nvPr/>
-        </p:nvSpPr>
-        <p:spPr>
-          <a:xfrm>
-            <a:off x="502920" y="1965960"/>
-            <a:ext cx="8686800" cy="640080"/>
-          </a:xfrm>
-          <a:prstGeom prst="rect">
-            <a:avLst/>
-          </a:prstGeom>
-          <a:noFill/>
-        </p:spPr>
-        <p:txBody>
-          <a:bodyPr wrap="square" lIns="0" tIns="0" rIns="0" bIns="0">
-            <a:spAutoFit/>
-          </a:bodyPr>
-          <a:lstStyle/>
-          <a:p>
-            <a:pPr algn="l"/>
-            <a:r>
-              <a:rPr sz="1400" b="0" i="0">
-                <a:solidFill>
-                  <a:srgbClr val="A0B4CC"/>
-                </a:solidFill>
-                <a:latin typeface="Calibri"/>
-              </a:rPr>
-              <a:t>I built this pipeline specifically to demonstrate readiness for the BIS Banking Department analytics role.</a:t>
-            </a:r>
-          </a:p>
-        </p:txBody>
-      </p:sp>
-      <p:sp>
-        <p:nvSpPr>
           <p:cNvPr id="6" name="Rectangle 5"/>
           <p:cNvSpPr/>
           <p:nvPr/>
@@ -4413,76 +4378,6 @@
           <a:p>
             <a:pPr algn="ctr"/>
             <a:endParaRPr/>
-          </a:p>
-        </p:txBody>
-      </p:sp>
-      <p:sp>
-        <p:nvSpPr>
-          <p:cNvPr id="16" name="TextBox 15"/>
-          <p:cNvSpPr txBox="1"/>
-          <p:nvPr/>
-        </p:nvSpPr>
-        <p:spPr>
-          <a:xfrm>
-            <a:off x="502920" y="5532120"/>
-            <a:ext cx="7315200" cy="502920"/>
-          </a:xfrm>
-          <a:prstGeom prst="rect">
-            <a:avLst/>
-          </a:prstGeom>
-          <a:noFill/>
-        </p:spPr>
-        <p:txBody>
-          <a:bodyPr wrap="square" lIns="0" tIns="0" rIns="0" bIns="0">
-            <a:spAutoFit/>
-          </a:bodyPr>
-          <a:lstStyle/>
-          <a:p>
-            <a:pPr algn="l"/>
-            <a:r>
-              <a:rPr sz="2200" b="1" i="0">
-                <a:solidFill>
-                  <a:srgbClr val="E8A020"/>
-                </a:solidFill>
-                <a:latin typeface="Calibri"/>
-              </a:rPr>
-              <a:t>Thank you</a:t>
-            </a:r>
-          </a:p>
-        </p:txBody>
-      </p:sp>
-      <p:sp>
-        <p:nvSpPr>
-          <p:cNvPr id="17" name="TextBox 16"/>
-          <p:cNvSpPr txBox="1"/>
-          <p:nvPr/>
-        </p:nvSpPr>
-        <p:spPr>
-          <a:xfrm>
-            <a:off x="502920" y="6053328"/>
-            <a:ext cx="9144000" cy="411480"/>
-          </a:xfrm>
-          <a:prstGeom prst="rect">
-            <a:avLst/>
-          </a:prstGeom>
-          <a:noFill/>
-        </p:spPr>
-        <p:txBody>
-          <a:bodyPr wrap="square" lIns="0" tIns="0" rIns="0" bIns="0">
-            <a:spAutoFit/>
-          </a:bodyPr>
-          <a:lstStyle/>
-          <a:p>
-            <a:pPr algn="l"/>
-            <a:r>
-              <a:rPr sz="1200" b="0" i="0">
-                <a:solidFill>
-                  <a:srgbClr val="A0B4CC"/>
-                </a:solidFill>
-                <a:latin typeface="Calibri"/>
-              </a:rPr>
-              <a:t>I look forward to contributing to the BIS Banking Department analytics team.</a:t>
-            </a:r>
           </a:p>
         </p:txBody>
       </p:sp>
@@ -18896,8 +18791,8 @@
           <a:noFill/>
         </p:spPr>
       </p:pic>
-      <mc:AlternateContent xmlns:mc="http://schemas.openxmlformats.org/markup-compatibility/2006">
-        <mc:Choice xmlns:we="http://schemas.microsoft.com/office/webextensions/webextension/2010/11" xmlns:pca="http://schemas.microsoft.com/office/powerpoint/2013/contentapp" Requires="we pca">
+      <mc:AlternateContent xmlns:mc="http://schemas.openxmlformats.org/markup-compatibility/2006" xmlns:we="http://schemas.microsoft.com/office/webextensions/webextension/2010/11" xmlns:pca="http://schemas.microsoft.com/office/powerpoint/2013/contentapp">
+        <mc:Choice Requires="we pca">
           <p:graphicFrame>
             <p:nvGraphicFramePr>
               <p:cNvPr id="2" name="Add-in" descr="Add-in content for Microsoft Power BI."/>
@@ -18917,7 +18812,7 @@
             </a:graphic>
           </p:graphicFrame>
         </mc:Choice>
-        <mc:Fallback>
+        <mc:Fallback xmlns="">
           <p:pic>
             <p:nvPicPr>
               <p:cNvPr id="2" name="Add-in" descr="Add-in content for Microsoft Power BI."/>

</xml_diff>